<commit_message>
Unit suite is 125, total 653: measured.json and everything that cites it
The three DATABASE_URL tests take the unit suite from 122 to 125 and the
total from 650 to 653. measured.json is updated first, then every line the
claims gate flagged across the docs, the public page's metric, table and
answer panel, and the design boards and review deck, which read the numbers
from measured.json and were regenerated.
</commit_message>
<xml_diff>
--- a/design/deck/RoadAssist-Bharat-Review.pptx
+++ b/design/deck/RoadAssist-Bharat-Review.pptx
@@ -211,7 +211,7 @@
                 <c:formatCode>General</c:formatCode>
                 <c:ptCount val="6"/>
                 <c:pt idx="0">
-                  <c:v>122</c:v>
+                  <c:v>125</c:v>
                 </c:pt>
                 <c:pt idx="1">
                   <c:v>189</c:v>
@@ -1817,7 +1817,7 @@
           <a:p>
             <a:r>
               <a:rPr lang="en-US" dirty="0"/>
-              <a:t>650 assertions across unit, end-to-end, concurrency, security, gateway security and browser suites, zero failures. The security suite attempts 74 attacks including cross-tenant reads, role escalation, SQL injection and forged tokens. The 22 payment-sandbox checks need an account we do not have, so they are reported as not run.</a:t>
+              <a:t>653 assertions across unit, end-to-end, concurrency, security, gateway security and browser suites, zero failures. The security suite attempts 74 attacks including cross-tenant reads, role escalation, SQL injection and forged tokens. The 22 payment-sandbox checks need an account we do not have, so they are reported as not run.</a:t>
             </a:r>
             <a:endParaRPr lang="en-US" dirty="0"/>
           </a:p>
@@ -12443,7 +12443,7 @@
                 <a:ea typeface="Bahnschrift" pitchFamily="34" charset="-122"/>
                 <a:cs typeface="Bahnschrift" pitchFamily="34" charset="-120"/>
               </a:rPr>
-              <a:t>650</a:t>
+              <a:t>653</a:t>
             </a:r>
             <a:endParaRPr lang="en-US" sz="6000" dirty="0"/>
           </a:p>

</xml_diff>

<commit_message>
Review deck rebuilt from measured.json: 672 assertions
</commit_message>
<xml_diff>
--- a/design/deck/RoadAssist-Bharat-Review.pptx
+++ b/design/deck/RoadAssist-Bharat-Review.pptx
@@ -211,7 +211,7 @@
                 <c:formatCode>General</c:formatCode>
                 <c:ptCount val="6"/>
                 <c:pt idx="0">
-                  <c:v>125</c:v>
+                  <c:v>144</c:v>
                 </c:pt>
                 <c:pt idx="1">
                   <c:v>189</c:v>
@@ -1817,7 +1817,7 @@
           <a:p>
             <a:r>
               <a:rPr lang="en-US" dirty="0"/>
-              <a:t>653 assertions across unit, end-to-end, concurrency, security, gateway security and browser suites, zero failures. The security suite attempts 74 attacks including cross-tenant reads, role escalation, SQL injection and forged tokens. The 22 payment-sandbox checks need an account we do not have, so they are reported as not run.</a:t>
+              <a:t>672 assertions across unit, end-to-end, concurrency, security, gateway security and browser suites, zero failures. The security suite attempts 74 attacks including cross-tenant reads, role escalation, SQL injection and forged tokens. The 22 payment-sandbox checks need an account we do not have, so they are reported as not run.</a:t>
             </a:r>
             <a:endParaRPr lang="en-US" dirty="0"/>
           </a:p>
@@ -12443,7 +12443,7 @@
                 <a:ea typeface="Bahnschrift" pitchFamily="34" charset="-122"/>
                 <a:cs typeface="Bahnschrift" pitchFamily="34" charset="-120"/>
               </a:rPr>
-              <a:t>653</a:t>
+              <a:t>672</a:t>
             </a:r>
             <a:endParaRPr lang="en-US" sz="6000" dirty="0"/>
           </a:p>

</xml_diff>